<commit_message>
Refactor project structure to kitchen-coach-app, clean up legacy assets, and update project docs
</commit_message>
<xml_diff>
--- a/ASQL_PROJECT_COMPLETED_v2.pptx
+++ b/ASQL_PROJECT_COMPLETED_v2.pptx
@@ -3648,7 +3648,7 @@
                 <a:ea typeface="+mn-ea"/>
                 <a:cs typeface="Times New Roman" panose="02020603050405020304" pitchFamily="18" charset="0"/>
               </a:rPr>
-              <a:t>WEIGHT COACH APP</a:t>
+              <a:t>KITCHEN COACH APP</a:t>
             </a:r>
             <a:endParaRPr lang="en-GB" sz="2800" b="1" dirty="0">
               <a:solidFill>
@@ -3696,7 +3696,7 @@
           <a:lstStyle/>
           <a:p>
             <a:r>
-              <a:rPr lang="en-US" sz="2200" b="1" i="0" dirty="0">
+              <a:rPr lang="en-US" sz="2200" b="1" dirty="0" i="0">
                 <a:solidFill>
                   <a:srgbClr val="FFFFFF"/>
                 </a:solidFill>
@@ -3708,7 +3708,7 @@
           </a:p>
           <a:p>
             <a:r>
-              <a:rPr lang="en-US" sz="2200" b="0" i="0" dirty="0">
+              <a:rPr lang="en-US" sz="2200" dirty="0" b="0" i="0">
                 <a:solidFill>
                   <a:srgbClr val="FFFFFF"/>
                 </a:solidFill>
@@ -3717,39 +3717,93 @@
               </a:rPr>
               <a:t>(RA2411003011741)</a:t>
             </a:r>
-          </a:p>
-          <a:p>
-            <a:endParaRPr lang="en-US" sz="2200" b="1" dirty="0">
-              <a:solidFill>
-                <a:srgbClr val="FFFFFF"/>
-              </a:solidFill>
-              <a:latin typeface="Times New Roman" panose="02020603050405020304" pitchFamily="18" charset="0"/>
-              <a:cs typeface="Times New Roman" panose="02020603050405020304" pitchFamily="18" charset="0"/>
-            </a:endParaRPr>
-          </a:p>
-          <a:p>
-            <a:r>
-              <a:rPr lang="en-US" sz="2200" b="0" i="0">
+            <a:r>
+              <a:rPr lang="en-GB" sz="2200" dirty="0">
                 <a:solidFill>
                   <a:srgbClr val="FFFFFF"/>
                 </a:solidFill>
                 <a:latin typeface="Times New Roman" panose="02020603050405020304" pitchFamily="18" charset="0"/>
                 <a:cs typeface="Times New Roman" panose="02020603050405020304" pitchFamily="18" charset="0"/>
               </a:rPr>
-              <a:t>Department</a:t>
-            </a:r>
-            <a:r>
-              <a:rPr lang="en-US" sz="2200" b="0" i="0" dirty="0">
+              <a:t/>
+            </a:r>
+            <a:r>
+              <a:rPr lang="en-US" sz="2200" dirty="0">
                 <a:solidFill>
                   <a:srgbClr val="FFFFFF"/>
                 </a:solidFill>
                 <a:latin typeface="Times New Roman" panose="02020603050405020304" pitchFamily="18" charset="0"/>
                 <a:cs typeface="Times New Roman" panose="02020603050405020304" pitchFamily="18" charset="0"/>
               </a:rPr>
-              <a:t>: CTECH</a:t>
-            </a:r>
-          </a:p>
-          <a:p>
+              <a:t/>
+            </a:r>
+          </a:p>
+          <a:p>
+            <a:r>
+              <a:rPr lang="en-US" sz="2200" b="1" dirty="0" i="0">
+                <a:solidFill>
+                  <a:srgbClr val="FFFFFF"/>
+                </a:solidFill>
+                <a:latin typeface="Times New Roman" panose="02020603050405020304" pitchFamily="18" charset="0"/>
+                <a:cs typeface="Times New Roman" panose="02020603050405020304" pitchFamily="18" charset="0"/>
+              </a:rPr>
+              <a:t>Riya Raj</a:t>
+            </a:r>
+          </a:p>
+          <a:p>
+            <a:r>
+              <a:rPr lang="en-US" sz="2200" dirty="0" b="0" i="0">
+                <a:solidFill>
+                  <a:srgbClr val="FFFFFF"/>
+                </a:solidFill>
+                <a:latin typeface="Times New Roman" panose="02020603050405020304" pitchFamily="18" charset="0"/>
+                <a:cs typeface="Times New Roman" panose="02020603050405020304" pitchFamily="18" charset="0"/>
+              </a:rPr>
+              <a:t>(RA2411003011753)</a:t>
+            </a:r>
+            <a:r>
+              <a:rPr lang="en-US" sz="2200" dirty="0" err="1">
+                <a:solidFill>
+                  <a:srgbClr val="FFFFFF"/>
+                </a:solidFill>
+                <a:latin typeface="Times New Roman" panose="02020603050405020304" pitchFamily="18" charset="0"/>
+                <a:cs typeface="Times New Roman" panose="02020603050405020304" pitchFamily="18" charset="0"/>
+              </a:rPr>
+              <a:t/>
+            </a:r>
+            <a:r>
+              <a:rPr lang="en-US" sz="2200" dirty="0">
+                <a:solidFill>
+                  <a:srgbClr val="FFFFFF"/>
+                </a:solidFill>
+                <a:latin typeface="Times New Roman" panose="02020603050405020304" pitchFamily="18" charset="0"/>
+                <a:cs typeface="Times New Roman" panose="02020603050405020304" pitchFamily="18" charset="0"/>
+              </a:rPr>
+              <a:t/>
+            </a:r>
+          </a:p>
+          <a:p>
+            <a:r>
+              <a:rPr lang="en-US" sz="2200" dirty="0" b="0" i="0">
+                <a:solidFill>
+                  <a:srgbClr val="FFFFFF"/>
+                </a:solidFill>
+                <a:latin typeface="Times New Roman" panose="02020603050405020304" pitchFamily="18" charset="0"/>
+                <a:cs typeface="Times New Roman" panose="02020603050405020304" pitchFamily="18" charset="0"/>
+              </a:rPr>
+              <a:t>Department: CTECH</a:t>
+            </a:r>
+          </a:p>
+          <a:p>
+            <a:r>
+              <a:rPr sz="2200" b="0" i="0">
+                <a:solidFill>
+                  <a:srgbClr val="FFFFFF"/>
+                </a:solidFill>
+                <a:latin typeface="Times New Roman"/>
+              </a:rPr>
+              <a:t/>
+            </a:r>
             <a:endParaRPr lang="en-US" sz="2000" dirty="0">
               <a:solidFill>
                 <a:srgbClr val="FFFFFF"/>
@@ -3760,7 +3814,7 @@
           </a:p>
           <a:p>
             <a:r>
-              <a:rPr lang="en-US" sz="2000" b="0" i="0" dirty="0">
+              <a:rPr lang="en-US" sz="2000" dirty="0" b="0" i="0">
                 <a:solidFill>
                   <a:srgbClr val="FFFFFF"/>
                 </a:solidFill>
@@ -5835,7 +5889,7 @@
               <a:rPr sz="1800" b="0" i="0">
                 <a:latin typeface="Times New Roman"/>
               </a:rPr>
-              <a:t>The Weight Coach App is a comprehensive database-driven application designed to help users manage their kitchen inventory, discover recipes based on available ingredients, track daily meal consumption, and monitor nutritional intake — all while reducing food waste. The system is built on a robust MySQL 8.0 relational database that demonstrates advanced SQL concepts covered in the 21CSC205P Database Management Systems course.</a:t>
+              <a:t>The Kitchen Coach App is a comprehensive database-driven application designed to help users manage their kitchen inventory, discover recipes based on available ingredients, track daily meal consumption, and monitor nutritional intake — all while reducing food waste. The system is built on a robust MySQL 8.0 relational database that demonstrates advanced SQL concepts covered in the 21CSC205P Database Management Systems course.</a:t>
             </a:r>
           </a:p>
           <a:p>
@@ -6014,7 +6068,7 @@
               <a:rPr sz="1700" b="0" i="0">
                 <a:latin typeface="Times New Roman"/>
               </a:rPr>
-              <a:t>In today's health-conscious world, managing nutrition effectively requires tracking what food is available, what meals are being consumed, and what nutritional value they provide. The Weight Coach App addresses this need by providing a unified platform for ingredient inventory management, recipe discovery, meal logging, and nutritional tracking.</a:t>
+              <a:t>In today's health-conscious world, managing nutrition effectively requires tracking what food is available, what meals are being consumed, and what nutritional value they provide. The Kitchen Coach App addresses this need by providing a unified platform for ingredient inventory management, recipe discovery, meal logging, and nutritional tracking.</a:t>
             </a:r>
           </a:p>
           <a:p>

</xml_diff>